<commit_message>
Actualiza pricing: $400k + 10% (principal) / $300k + 15% (alternativa)
Co-Authored-By: Claude Opus 4.8 <noreply@anthropic.com>
</commit_message>
<xml_diff>
--- a/propuesta-lucrecia-moreno.pptx
+++ b/propuesta-lucrecia-moreno.pptx
@@ -10697,7 +10697,7 @@
                 </a:solidFill>
                 <a:latin typeface="Georgia"/>
               </a:rPr>
-              <a:t>$500.000</a:t>
+              <a:t>$400.000</a:t>
             </a:r>
           </a:p>
         </p:txBody>
@@ -11243,7 +11243,7 @@
                 </a:solidFill>
                 <a:latin typeface="Segoe UI"/>
               </a:rPr>
-              <a:t>$400.000 de honorario + 15% sobre esas operaciones.</a:t>
+              <a:t>$300.000 de honorario + 15% sobre esas operaciones.</a:t>
             </a:r>
           </a:p>
         </p:txBody>

</xml_diff>